<commit_message>
Update fig1, fig3 code and data files
- Update fig1.py with improvements
- Replace fig3.py with fig3_v3.py (new version)
- Add new data source files (Zhang_SourceData)
- Update figures and data CSV
- Add test notebook
</commit_message>
<xml_diff>
--- a/code/Figure2.pptx
+++ b/code/Figure2.pptx
@@ -118,6 +118,22 @@
 <file path=ppt/changesInfos/changesInfo1.xml><?xml version="1.0" encoding="utf-8"?>
 <pc:chgInfo xmlns:a="http://schemas.openxmlformats.org/drawingml/2006/main" xmlns:r="http://schemas.openxmlformats.org/officeDocument/2006/relationships" xmlns:ac="http://schemas.microsoft.com/office/drawing/2013/main/command" xmlns:pc="http://schemas.microsoft.com/office/powerpoint/2013/main/command">
   <pc:docChgLst>
+    <pc:chgData name="永强 张" userId="afbc5eaa9bdcb7d2" providerId="LiveId" clId="{131A4910-1A1C-4F27-8286-FBE7D8F117CF}"/>
+    <pc:docChg chg="undo custSel modSld">
+      <pc:chgData name="永强 张" userId="afbc5eaa9bdcb7d2" providerId="LiveId" clId="{131A4910-1A1C-4F27-8286-FBE7D8F117CF}" dt="2024-08-29T12:13:31.829" v="31" actId="1036"/>
+      <pc:docMkLst>
+        <pc:docMk/>
+      </pc:docMkLst>
+      <pc:sldChg chg="modSp mod">
+        <pc:chgData name="永强 张" userId="afbc5eaa9bdcb7d2" providerId="LiveId" clId="{131A4910-1A1C-4F27-8286-FBE7D8F117CF}" dt="2024-08-29T12:13:31.829" v="31" actId="1036"/>
+        <pc:sldMkLst>
+          <pc:docMk/>
+          <pc:sldMk cId="729997344" sldId="375"/>
+        </pc:sldMkLst>
+      </pc:sldChg>
+    </pc:docChg>
+  </pc:docChgLst>
+  <pc:docChgLst>
     <pc:chgData name="永强 张" userId="afbc5eaa9bdcb7d2" providerId="LiveId" clId="{469186B9-1096-4A72-97B2-FBC95EEA4062}"/>
     <pc:docChg chg="undo custSel delSld modSld">
       <pc:chgData name="永强 张" userId="afbc5eaa9bdcb7d2" providerId="LiveId" clId="{469186B9-1096-4A72-97B2-FBC95EEA4062}" dt="2024-06-07T22:24:56.673" v="1220" actId="478"/>
@@ -204,6 +220,69 @@
     </pc:docChg>
   </pc:docChgLst>
   <pc:docChgLst>
+    <pc:chgData name="永强 张" userId="afbc5eaa9bdcb7d2" providerId="LiveId" clId="{39A592AA-A638-46FB-A9BE-3420764008D0}"/>
+    <pc:docChg chg="undo custSel modSld">
+      <pc:chgData name="永强 张" userId="afbc5eaa9bdcb7d2" providerId="LiveId" clId="{39A592AA-A638-46FB-A9BE-3420764008D0}" dt="2025-09-09T06:30:11.245" v="19" actId="14100"/>
+      <pc:docMkLst>
+        <pc:docMk/>
+      </pc:docMkLst>
+      <pc:sldChg chg="modSp mod">
+        <pc:chgData name="永强 张" userId="afbc5eaa9bdcb7d2" providerId="LiveId" clId="{39A592AA-A638-46FB-A9BE-3420764008D0}" dt="2025-09-09T06:30:11.245" v="19" actId="14100"/>
+        <pc:sldMkLst>
+          <pc:docMk/>
+          <pc:sldMk cId="729997344" sldId="375"/>
+        </pc:sldMkLst>
+      </pc:sldChg>
+      <pc:sldChg chg="modSp mod">
+        <pc:chgData name="永强 张" userId="afbc5eaa9bdcb7d2" providerId="LiveId" clId="{39A592AA-A638-46FB-A9BE-3420764008D0}" dt="2025-09-09T00:59:39.621" v="9" actId="108"/>
+        <pc:sldMkLst>
+          <pc:docMk/>
+          <pc:sldMk cId="601660394" sldId="396"/>
+        </pc:sldMkLst>
+      </pc:sldChg>
+    </pc:docChg>
+  </pc:docChgLst>
+  <pc:docChgLst>
+    <pc:chgData name="Longhao Wang" userId="2964de736bda0b76" providerId="LiveId" clId="{1369B886-08A3-4EC3-A822-266529B4CD55}"/>
+    <pc:docChg chg="undo custSel modSld">
+      <pc:chgData name="Longhao Wang" userId="2964de736bda0b76" providerId="LiveId" clId="{1369B886-08A3-4EC3-A822-266529B4CD55}" dt="2025-09-28T06:38:57.835" v="5" actId="207"/>
+      <pc:docMkLst>
+        <pc:docMk/>
+      </pc:docMkLst>
+      <pc:sldChg chg="modSp mod">
+        <pc:chgData name="Longhao Wang" userId="2964de736bda0b76" providerId="LiveId" clId="{1369B886-08A3-4EC3-A822-266529B4CD55}" dt="2025-09-28T06:38:57.835" v="5" actId="207"/>
+        <pc:sldMkLst>
+          <pc:docMk/>
+          <pc:sldMk cId="1025388427" sldId="398"/>
+        </pc:sldMkLst>
+        <pc:spChg chg="mod">
+          <ac:chgData name="Longhao Wang" userId="2964de736bda0b76" providerId="LiveId" clId="{1369B886-08A3-4EC3-A822-266529B4CD55}" dt="2025-09-28T06:38:57.835" v="5" actId="207"/>
+          <ac:spMkLst>
+            <pc:docMk/>
+            <pc:sldMk cId="1025388427" sldId="398"/>
+            <ac:spMk id="107" creationId="{F3FE46F2-ED61-3D9C-C657-C51852992F48}"/>
+          </ac:spMkLst>
+        </pc:spChg>
+      </pc:sldChg>
+    </pc:docChg>
+  </pc:docChgLst>
+  <pc:docChgLst>
+    <pc:chgData name="永强 张" userId="afbc5eaa9bdcb7d2" providerId="LiveId" clId="{5E73A565-FDD1-4674-986C-9AEB00825018}"/>
+    <pc:docChg chg="custSel modSld">
+      <pc:chgData name="永强 张" userId="afbc5eaa9bdcb7d2" providerId="LiveId" clId="{5E73A565-FDD1-4674-986C-9AEB00825018}" dt="2024-02-26T00:19:31.895" v="13" actId="1076"/>
+      <pc:docMkLst>
+        <pc:docMk/>
+      </pc:docMkLst>
+      <pc:sldChg chg="addSp delSp modSp mod">
+        <pc:chgData name="永强 张" userId="afbc5eaa9bdcb7d2" providerId="LiveId" clId="{5E73A565-FDD1-4674-986C-9AEB00825018}" dt="2024-02-26T00:19:31.895" v="13" actId="1076"/>
+        <pc:sldMkLst>
+          <pc:docMk/>
+          <pc:sldMk cId="4068733144" sldId="389"/>
+        </pc:sldMkLst>
+      </pc:sldChg>
+    </pc:docChg>
+  </pc:docChgLst>
+  <pc:docChgLst>
     <pc:chgData name="张 永强" userId="afbc5eaa9bdcb7d2" providerId="LiveId" clId="{5E73A565-FDD1-4674-986C-9AEB00825018}"/>
     <pc:docChg chg="undo custSel addSld delSld modSld">
       <pc:chgData name="张 永强" userId="afbc5eaa9bdcb7d2" providerId="LiveId" clId="{5E73A565-FDD1-4674-986C-9AEB00825018}" dt="2024-02-22T03:44:52.128" v="6840" actId="164"/>
@@ -282,85 +361,6 @@
       </pc:sldChg>
     </pc:docChg>
   </pc:docChgLst>
-  <pc:docChgLst>
-    <pc:chgData name="永强 张" userId="afbc5eaa9bdcb7d2" providerId="LiveId" clId="{39A592AA-A638-46FB-A9BE-3420764008D0}"/>
-    <pc:docChg chg="undo custSel modSld">
-      <pc:chgData name="永强 张" userId="afbc5eaa9bdcb7d2" providerId="LiveId" clId="{39A592AA-A638-46FB-A9BE-3420764008D0}" dt="2025-09-09T06:30:11.245" v="19" actId="14100"/>
-      <pc:docMkLst>
-        <pc:docMk/>
-      </pc:docMkLst>
-      <pc:sldChg chg="modSp mod">
-        <pc:chgData name="永强 张" userId="afbc5eaa9bdcb7d2" providerId="LiveId" clId="{39A592AA-A638-46FB-A9BE-3420764008D0}" dt="2025-09-09T06:30:11.245" v="19" actId="14100"/>
-        <pc:sldMkLst>
-          <pc:docMk/>
-          <pc:sldMk cId="729997344" sldId="375"/>
-        </pc:sldMkLst>
-        <pc:spChg chg="mod">
-          <ac:chgData name="永强 张" userId="afbc5eaa9bdcb7d2" providerId="LiveId" clId="{39A592AA-A638-46FB-A9BE-3420764008D0}" dt="2025-09-09T02:33:51.071" v="10" actId="1076"/>
-          <ac:spMkLst>
-            <pc:docMk/>
-            <pc:sldMk cId="729997344" sldId="375"/>
-            <ac:spMk id="4" creationId="{F96924CC-BD58-32A1-FAFB-8EAB93D7C6F6}"/>
-          </ac:spMkLst>
-        </pc:spChg>
-        <pc:picChg chg="mod">
-          <ac:chgData name="永强 张" userId="afbc5eaa9bdcb7d2" providerId="LiveId" clId="{39A592AA-A638-46FB-A9BE-3420764008D0}" dt="2025-09-09T06:30:11.245" v="19" actId="14100"/>
-          <ac:picMkLst>
-            <pc:docMk/>
-            <pc:sldMk cId="729997344" sldId="375"/>
-            <ac:picMk id="5" creationId="{646E5E15-19E8-0EA9-3971-B63EE2F74494}"/>
-          </ac:picMkLst>
-        </pc:picChg>
-      </pc:sldChg>
-      <pc:sldChg chg="modSp mod">
-        <pc:chgData name="永强 张" userId="afbc5eaa9bdcb7d2" providerId="LiveId" clId="{39A592AA-A638-46FB-A9BE-3420764008D0}" dt="2025-09-09T00:59:39.621" v="9" actId="108"/>
-        <pc:sldMkLst>
-          <pc:docMk/>
-          <pc:sldMk cId="601660394" sldId="396"/>
-        </pc:sldMkLst>
-        <pc:spChg chg="mod">
-          <ac:chgData name="永强 张" userId="afbc5eaa9bdcb7d2" providerId="LiveId" clId="{39A592AA-A638-46FB-A9BE-3420764008D0}" dt="2025-09-09T00:59:39.621" v="9" actId="108"/>
-          <ac:spMkLst>
-            <pc:docMk/>
-            <pc:sldMk cId="601660394" sldId="396"/>
-            <ac:spMk id="87" creationId="{7C1C00B2-0305-F2F3-CC8D-9CC6E0E4F2A4}"/>
-          </ac:spMkLst>
-        </pc:spChg>
-      </pc:sldChg>
-    </pc:docChg>
-  </pc:docChgLst>
-  <pc:docChgLst>
-    <pc:chgData name="永强 张" userId="afbc5eaa9bdcb7d2" providerId="LiveId" clId="{131A4910-1A1C-4F27-8286-FBE7D8F117CF}"/>
-    <pc:docChg chg="undo custSel modSld">
-      <pc:chgData name="永强 张" userId="afbc5eaa9bdcb7d2" providerId="LiveId" clId="{131A4910-1A1C-4F27-8286-FBE7D8F117CF}" dt="2024-08-29T12:13:31.829" v="31" actId="1036"/>
-      <pc:docMkLst>
-        <pc:docMk/>
-      </pc:docMkLst>
-      <pc:sldChg chg="modSp mod">
-        <pc:chgData name="永强 张" userId="afbc5eaa9bdcb7d2" providerId="LiveId" clId="{131A4910-1A1C-4F27-8286-FBE7D8F117CF}" dt="2024-08-29T12:13:31.829" v="31" actId="1036"/>
-        <pc:sldMkLst>
-          <pc:docMk/>
-          <pc:sldMk cId="729997344" sldId="375"/>
-        </pc:sldMkLst>
-      </pc:sldChg>
-    </pc:docChg>
-  </pc:docChgLst>
-  <pc:docChgLst>
-    <pc:chgData name="永强 张" userId="afbc5eaa9bdcb7d2" providerId="LiveId" clId="{5E73A565-FDD1-4674-986C-9AEB00825018}"/>
-    <pc:docChg chg="custSel modSld">
-      <pc:chgData name="永强 张" userId="afbc5eaa9bdcb7d2" providerId="LiveId" clId="{5E73A565-FDD1-4674-986C-9AEB00825018}" dt="2024-02-26T00:19:31.895" v="13" actId="1076"/>
-      <pc:docMkLst>
-        <pc:docMk/>
-      </pc:docMkLst>
-      <pc:sldChg chg="addSp delSp modSp mod">
-        <pc:chgData name="永强 张" userId="afbc5eaa9bdcb7d2" providerId="LiveId" clId="{5E73A565-FDD1-4674-986C-9AEB00825018}" dt="2024-02-26T00:19:31.895" v="13" actId="1076"/>
-        <pc:sldMkLst>
-          <pc:docMk/>
-          <pc:sldMk cId="4068733144" sldId="389"/>
-        </pc:sldMkLst>
-      </pc:sldChg>
-    </pc:docChg>
-  </pc:docChgLst>
 </pc:chgInfo>
 </file>
 
@@ -446,7 +446,7 @@
           <a:p>
             <a:fld id="{2CFE996E-9571-4836-B92D-364DA66D326D}" type="datetimeFigureOut">
               <a:rPr lang="zh-CN" altLang="en-US" smtClean="0"/>
-              <a:t>2025/9/13</a:t>
+              <a:t>2025/9/28</a:t>
             </a:fld>
             <a:endParaRPr lang="zh-CN" altLang="en-US"/>
           </a:p>
@@ -844,7 +844,7 @@
           <a:p>
             <a:fld id="{80D0422E-2A2B-4B66-B63F-B7AA4D5BF47B}" type="datetimeFigureOut">
               <a:rPr lang="zh-CN" altLang="en-US" smtClean="0"/>
-              <a:t>2025/9/13</a:t>
+              <a:t>2025/9/28</a:t>
             </a:fld>
             <a:endParaRPr lang="zh-CN" altLang="en-US"/>
           </a:p>
@@ -1014,7 +1014,7 @@
           <a:p>
             <a:fld id="{80D0422E-2A2B-4B66-B63F-B7AA4D5BF47B}" type="datetimeFigureOut">
               <a:rPr lang="zh-CN" altLang="en-US" smtClean="0"/>
-              <a:t>2025/9/13</a:t>
+              <a:t>2025/9/28</a:t>
             </a:fld>
             <a:endParaRPr lang="zh-CN" altLang="en-US"/>
           </a:p>
@@ -1194,7 +1194,7 @@
           <a:p>
             <a:fld id="{80D0422E-2A2B-4B66-B63F-B7AA4D5BF47B}" type="datetimeFigureOut">
               <a:rPr lang="zh-CN" altLang="en-US" smtClean="0"/>
-              <a:t>2025/9/13</a:t>
+              <a:t>2025/9/28</a:t>
             </a:fld>
             <a:endParaRPr lang="zh-CN" altLang="en-US"/>
           </a:p>
@@ -1364,7 +1364,7 @@
           <a:p>
             <a:fld id="{80D0422E-2A2B-4B66-B63F-B7AA4D5BF47B}" type="datetimeFigureOut">
               <a:rPr lang="zh-CN" altLang="en-US" smtClean="0"/>
-              <a:t>2025/9/13</a:t>
+              <a:t>2025/9/28</a:t>
             </a:fld>
             <a:endParaRPr lang="zh-CN" altLang="en-US"/>
           </a:p>
@@ -1608,7 +1608,7 @@
           <a:p>
             <a:fld id="{80D0422E-2A2B-4B66-B63F-B7AA4D5BF47B}" type="datetimeFigureOut">
               <a:rPr lang="zh-CN" altLang="en-US" smtClean="0"/>
-              <a:t>2025/9/13</a:t>
+              <a:t>2025/9/28</a:t>
             </a:fld>
             <a:endParaRPr lang="zh-CN" altLang="en-US"/>
           </a:p>
@@ -1840,7 +1840,7 @@
           <a:p>
             <a:fld id="{80D0422E-2A2B-4B66-B63F-B7AA4D5BF47B}" type="datetimeFigureOut">
               <a:rPr lang="zh-CN" altLang="en-US" smtClean="0"/>
-              <a:t>2025/9/13</a:t>
+              <a:t>2025/9/28</a:t>
             </a:fld>
             <a:endParaRPr lang="zh-CN" altLang="en-US"/>
           </a:p>
@@ -2207,7 +2207,7 @@
           <a:p>
             <a:fld id="{80D0422E-2A2B-4B66-B63F-B7AA4D5BF47B}" type="datetimeFigureOut">
               <a:rPr lang="zh-CN" altLang="en-US" smtClean="0"/>
-              <a:t>2025/9/13</a:t>
+              <a:t>2025/9/28</a:t>
             </a:fld>
             <a:endParaRPr lang="zh-CN" altLang="en-US"/>
           </a:p>
@@ -2325,7 +2325,7 @@
           <a:p>
             <a:fld id="{80D0422E-2A2B-4B66-B63F-B7AA4D5BF47B}" type="datetimeFigureOut">
               <a:rPr lang="zh-CN" altLang="en-US" smtClean="0"/>
-              <a:t>2025/9/13</a:t>
+              <a:t>2025/9/28</a:t>
             </a:fld>
             <a:endParaRPr lang="zh-CN" altLang="en-US"/>
           </a:p>
@@ -2420,7 +2420,7 @@
           <a:p>
             <a:fld id="{80D0422E-2A2B-4B66-B63F-B7AA4D5BF47B}" type="datetimeFigureOut">
               <a:rPr lang="zh-CN" altLang="en-US" smtClean="0"/>
-              <a:t>2025/9/13</a:t>
+              <a:t>2025/9/28</a:t>
             </a:fld>
             <a:endParaRPr lang="zh-CN" altLang="en-US"/>
           </a:p>
@@ -2697,7 +2697,7 @@
           <a:p>
             <a:fld id="{80D0422E-2A2B-4B66-B63F-B7AA4D5BF47B}" type="datetimeFigureOut">
               <a:rPr lang="zh-CN" altLang="en-US" smtClean="0"/>
-              <a:t>2025/9/13</a:t>
+              <a:t>2025/9/28</a:t>
             </a:fld>
             <a:endParaRPr lang="zh-CN" altLang="en-US"/>
           </a:p>
@@ -2954,7 +2954,7 @@
           <a:p>
             <a:fld id="{80D0422E-2A2B-4B66-B63F-B7AA4D5BF47B}" type="datetimeFigureOut">
               <a:rPr lang="zh-CN" altLang="en-US" smtClean="0"/>
-              <a:t>2025/9/13</a:t>
+              <a:t>2025/9/28</a:t>
             </a:fld>
             <a:endParaRPr lang="zh-CN" altLang="en-US"/>
           </a:p>
@@ -3167,7 +3167,7 @@
           <a:p>
             <a:fld id="{80D0422E-2A2B-4B66-B63F-B7AA4D5BF47B}" type="datetimeFigureOut">
               <a:rPr lang="zh-CN" altLang="en-US" smtClean="0"/>
-              <a:t>2025/9/13</a:t>
+              <a:t>2025/9/28</a:t>
             </a:fld>
             <a:endParaRPr lang="zh-CN" altLang="en-US"/>
           </a:p>
@@ -4686,7 +4686,7 @@
           <p:spPr>
             <a:xfrm>
               <a:off x="3780845" y="3510323"/>
-              <a:ext cx="1329210" cy="430887"/>
+              <a:ext cx="1893467" cy="430887"/>
             </a:xfrm>
             <a:prstGeom prst="rect">
               <a:avLst/>
@@ -4707,9 +4707,21 @@
             <a:p>
               <a:r>
                 <a:rPr lang="en-US" altLang="zh-CN" sz="1100" b="1" i="1" dirty="0"/>
-                <a:t>434.6 ± 21.3  </a:t>
+                <a:t>434.6 ± 21.3 </a:t>
               </a:r>
-              <a:endParaRPr lang="zh-CN" altLang="en-US" sz="1100" b="1" i="1" dirty="0"/>
+              <a:r>
+                <a:rPr lang="en-US" altLang="zh-CN" sz="1100" b="1" i="1" dirty="0">
+                  <a:solidFill>
+                    <a:srgbClr val="EE0000"/>
+                  </a:solidFill>
+                </a:rPr>
+                <a:t>/ 445.5 ± 22.9   </a:t>
+              </a:r>
+              <a:endParaRPr lang="zh-CN" altLang="en-US" sz="1100" b="1" i="1" dirty="0">
+                <a:solidFill>
+                  <a:srgbClr val="EE0000"/>
+                </a:solidFill>
+              </a:endParaRPr>
             </a:p>
           </p:txBody>
         </p:sp>

</xml_diff>